<commit_message>
Add live SQLite dashboard and fix review issues
Adds the live repository dashboard (overview, zones, analytics, data,
forecast, controls), its tests and assets, and fixes issues found in review:

- Show sensor_data readings alongside zone telemetry instead of hiding them
- Fix Zones detail crash for zones without telemetry
- Correct inverted low-temperature forecast risk
- Seed all configured zones from ZONE_PROFILES
- Skip redelivered MQTT messages; store alert state matching the alert flag
- Resend a message after the publisher reconnects
- Label times in the correct time zone; consistent zone status
- Remove unused code, add pytest.ini, update run guides

Co-Authored-By: Claude Opus 5.5 <noreply@anthropic.com>
</commit_message>
<xml_diff>
--- a/GreenHouseWatch_Jerry_Diabor.pptx
+++ b/GreenHouseWatch_Jerry_Diabor.pptx
@@ -5,7 +5,7 @@
     <p:sldMasterId id="2147483648" r:id="rId1"/>
   </p:sldMasterIdLst>
   <p:notesMasterIdLst>
-    <p:notesMasterId r:id="rId14"/>
+    <p:notesMasterId r:id="rId15"/>
   </p:notesMasterIdLst>
   <p:sldIdLst>
     <p:sldId id="256" r:id="rId2"/>
@@ -18,8 +18,9 @@
     <p:sldId id="263" r:id="rId9"/>
     <p:sldId id="264" r:id="rId10"/>
     <p:sldId id="265" r:id="rId11"/>
-    <p:sldId id="266" r:id="rId12"/>
-    <p:sldId id="267" r:id="rId13"/>
+    <p:sldId id="268" r:id="rId12"/>
+    <p:sldId id="266" r:id="rId13"/>
+    <p:sldId id="267" r:id="rId14"/>
   </p:sldIdLst>
   <p:sldSz cx="12192000" cy="6858000"/>
   <p:notesSz cx="6858000" cy="12192000"/>
@@ -127,8 +128,8 @@
 <pc:chgInfo xmlns:a="http://schemas.openxmlformats.org/drawingml/2006/main" xmlns:r="http://schemas.openxmlformats.org/officeDocument/2006/relationships" xmlns:ac="http://schemas.microsoft.com/office/drawing/2013/main/command" xmlns:pc="http://schemas.microsoft.com/office/powerpoint/2013/main/command">
   <pc:docChgLst>
     <pc:chgData name="Jerry Godwin" userId="83472b140ea390e8" providerId="LiveId" clId="{ED87FD99-202B-4469-A191-727189A2DD0E}"/>
-    <pc:docChg chg="modSld">
-      <pc:chgData name="Jerry Godwin" userId="83472b140ea390e8" providerId="LiveId" clId="{ED87FD99-202B-4469-A191-727189A2DD0E}" dt="2026-09-16T19:19:21.529" v="11" actId="20577"/>
+    <pc:docChg chg="addSld modSld">
+      <pc:chgData name="Jerry Godwin" userId="83472b140ea390e8" providerId="LiveId" clId="{ED87FD99-202B-4469-A191-727189A2DD0E}" dt="2026-09-28T17:21:36.657" v="15" actId="680"/>
       <pc:docMkLst>
         <pc:docMk/>
       </pc:docMkLst>
@@ -171,11 +172,27 @@
         </pc:spChg>
       </pc:sldChg>
       <pc:sldChg chg="modSp mod">
-        <pc:chgData name="Jerry Godwin" userId="83472b140ea390e8" providerId="LiveId" clId="{ED87FD99-202B-4469-A191-727189A2DD0E}" dt="2026-09-16T19:19:05.802" v="9" actId="20577"/>
+        <pc:chgData name="Jerry Godwin" userId="83472b140ea390e8" providerId="LiveId" clId="{ED87FD99-202B-4469-A191-727189A2DD0E}" dt="2026-09-28T17:21:28.065" v="14" actId="1076"/>
         <pc:sldMkLst>
           <pc:docMk/>
           <pc:sldMk cId="0" sldId="265"/>
         </pc:sldMkLst>
+        <pc:spChg chg="mod">
+          <ac:chgData name="Jerry Godwin" userId="83472b140ea390e8" providerId="LiveId" clId="{ED87FD99-202B-4469-A191-727189A2DD0E}" dt="2026-09-28T17:21:28.065" v="14" actId="1076"/>
+          <ac:spMkLst>
+            <pc:docMk/>
+            <pc:sldMk cId="0" sldId="265"/>
+            <ac:spMk id="9" creationId="{00000000-0000-0000-0000-000000000000}"/>
+          </ac:spMkLst>
+        </pc:spChg>
+        <pc:spChg chg="mod">
+          <ac:chgData name="Jerry Godwin" userId="83472b140ea390e8" providerId="LiveId" clId="{ED87FD99-202B-4469-A191-727189A2DD0E}" dt="2026-09-28T17:21:26.672" v="13" actId="20577"/>
+          <ac:spMkLst>
+            <pc:docMk/>
+            <pc:sldMk cId="0" sldId="265"/>
+            <ac:spMk id="10" creationId="{00000000-0000-0000-0000-000000000000}"/>
+          </ac:spMkLst>
+        </pc:spChg>
         <pc:spChg chg="mod">
           <ac:chgData name="Jerry Godwin" userId="83472b140ea390e8" providerId="LiveId" clId="{ED87FD99-202B-4469-A191-727189A2DD0E}" dt="2026-09-16T19:19:05.802" v="9" actId="20577"/>
           <ac:spMkLst>
@@ -199,6 +216,13 @@
             <ac:spMk id="8" creationId="{00000000-0000-0000-0000-000000000000}"/>
           </ac:spMkLst>
         </pc:spChg>
+      </pc:sldChg>
+      <pc:sldChg chg="new">
+        <pc:chgData name="Jerry Godwin" userId="83472b140ea390e8" providerId="LiveId" clId="{ED87FD99-202B-4469-A191-727189A2DD0E}" dt="2026-09-28T17:21:36.657" v="15" actId="680"/>
+        <pc:sldMkLst>
+          <pc:docMk/>
+          <pc:sldMk cId="935790242" sldId="268"/>
+        </pc:sldMkLst>
       </pc:sldChg>
     </pc:docChg>
   </pc:docChgLst>
@@ -563,7 +587,7 @@
           <a:p>
             <a:fld id="{F7021451-1387-4CA6-816F-3879F97B5CBC}" type="slidenum">
               <a:rPr lang="en-US"/>
-              <a:t>11</a:t>
+              <a:t>12</a:t>
             </a:fld>
             <a:endParaRPr lang="en-US"/>
           </a:p>
@@ -647,7 +671,7 @@
           <a:p>
             <a:fld id="{F7021451-1387-4CA6-816F-3879F97B5CBC}" type="slidenum">
               <a:rPr lang="en-US"/>
-              <a:t>12</a:t>
+              <a:t>13</a:t>
             </a:fld>
             <a:endParaRPr lang="en-US"/>
           </a:p>
@@ -2301,7 +2325,7 @@
         </p:nvSpPr>
         <p:spPr>
           <a:xfrm>
-            <a:off x="6172200" y="1188720"/>
+            <a:off x="6126480" y="1219558"/>
             <a:ext cx="5577840" cy="4754880"/>
           </a:xfrm>
           <a:prstGeom prst="roundRect">
@@ -2360,7 +2384,7 @@
                 <a:ea typeface="Arial" pitchFamily="34" charset="-122"/>
                 <a:cs typeface="Arial" pitchFamily="34" charset="-120"/>
               </a:rPr>
-              <a:t>Preferred — live MQTT</a:t>
+              <a:t>Preferred - live MQTT</a:t>
             </a:r>
             <a:endParaRPr lang="en-US" sz="1600" dirty="0"/>
           </a:p>
@@ -2669,6 +2693,36 @@
 </file>
 
 <file path=ppt/slides/slide11.xml><?xml version="1.0" encoding="utf-8"?>
+<p:sld xmlns:a="http://schemas.openxmlformats.org/drawingml/2006/main" xmlns:r="http://schemas.openxmlformats.org/officeDocument/2006/relationships" xmlns:p="http://schemas.openxmlformats.org/presentationml/2006/main">
+  <p:cSld>
+    <p:spTree>
+      <p:nvGrpSpPr>
+        <p:cNvPr id="1" name=""/>
+        <p:cNvGrpSpPr/>
+        <p:nvPr/>
+      </p:nvGrpSpPr>
+      <p:grpSpPr>
+        <a:xfrm>
+          <a:off x="0" y="0"/>
+          <a:ext cx="0" cy="0"/>
+          <a:chOff x="0" y="0"/>
+          <a:chExt cx="0" cy="0"/>
+        </a:xfrm>
+      </p:grpSpPr>
+    </p:spTree>
+    <p:extLst>
+      <p:ext uri="{BB962C8B-B14F-4D97-AF65-F5344CB8AC3E}">
+        <p14:creationId xmlns:p14="http://schemas.microsoft.com/office/powerpoint/2010/main" val="935790242"/>
+      </p:ext>
+    </p:extLst>
+  </p:cSld>
+  <p:clrMapOvr>
+    <a:masterClrMapping/>
+  </p:clrMapOvr>
+</p:sld>
+</file>
+
+<file path=ppt/slides/slide12.xml><?xml version="1.0" encoding="utf-8"?>
 <p:sld xmlns:a="http://schemas.openxmlformats.org/drawingml/2006/main" xmlns:r="http://schemas.openxmlformats.org/officeDocument/2006/relationships" xmlns:p="http://schemas.openxmlformats.org/presentationml/2006/main">
   <p:cSld name="Slide 11">
     <p:bg>
@@ -3593,7 +3647,7 @@
 </p:sld>
 </file>
 
-<file path=ppt/slides/slide12.xml><?xml version="1.0" encoding="utf-8"?>
+<file path=ppt/slides/slide13.xml><?xml version="1.0" encoding="utf-8"?>
 <p:sld xmlns:a="http://schemas.openxmlformats.org/drawingml/2006/main" xmlns:r="http://schemas.openxmlformats.org/officeDocument/2006/relationships" xmlns:p="http://schemas.openxmlformats.org/presentationml/2006/main">
   <p:cSld name="Slide 12">
     <p:bg>

</xml_diff>